<commit_message>
final 7-slide deck + README accuracy fixes (Flask demo, deck naming)
</commit_message>
<xml_diff>
--- a/submission/FlytWatch_Final_2slides.pptx
+++ b/submission/FlytWatch_Final_2slides.pptx
@@ -1796,7 +1796,7 @@
                 <a:ea typeface="Cambria" pitchFamily="34" charset="-122"/>
                 <a:cs typeface="Cambria" pitchFamily="34" charset="-120"/>
               </a:rPr>
-              <a:t>44.1 / 100</a:t>
+              <a:t>53.5 / 100</a:t>
             </a:r>
             <a:endParaRPr lang="en-US" sz="3200" dirty="0"/>
           </a:p>
@@ -1838,7 +1838,7 @@
                 <a:ea typeface="Calibri" pitchFamily="34" charset="-122"/>
                 <a:cs typeface="Calibri" pitchFamily="34" charset="-120"/>
               </a:rPr>
-              <a:t>practice benchmark — from a 35.6 zero-shot floor, in two scored iterations</a:t>
+              <a:t>final evaluation — 1st place at submission, +4.0 reasoning bonus (field best)</a:t>
             </a:r>
             <a:endParaRPr lang="en-US" sz="1100" dirty="0"/>
           </a:p>
@@ -1877,7 +1877,7 @@
                 <a:ea typeface="Cambria" pitchFamily="34" charset="-122"/>
                 <a:cs typeface="Cambria" pitchFamily="34" charset="-120"/>
               </a:rPr>
-              <a:t>21 / 35</a:t>
+              <a:t>6 → 49.5</a:t>
             </a:r>
             <a:endParaRPr lang="en-US" sz="3200" dirty="0"/>
           </a:p>
@@ -1919,7 +1919,7 @@
                 <a:ea typeface="Calibri" pitchFamily="34" charset="-122"/>
                 <a:cs typeface="Calibri" pitchFamily="34" charset="-120"/>
               </a:rPr>
-              <a:t>Difficulty 2 (timing) — all six events localised, IoU 0.58–0.86</a:t>
+              <a:t>marks climbed across five scored runs: measure, retune, resubmit</a:t>
             </a:r>
             <a:endParaRPr lang="en-US" sz="1100" dirty="0"/>
           </a:p>

</xml_diff>